<commit_message>
updated markdown with calibration logic
</commit_message>
<xml_diff>
--- a/presentation.pptx
+++ b/presentation.pptx
@@ -7769,7 +7769,7 @@
         </p:nvSpPr>
         <p:spPr>
           <a:xfrm>
-            <a:off x="1705799" y="1973853"/>
+            <a:off x="2162244" y="2034533"/>
             <a:ext cx="8777226" cy="3318582"/>
           </a:xfrm>
           <a:prstGeom prst="rect">
@@ -8136,7 +8136,7 @@
         </p:blipFill>
         <p:spPr>
           <a:xfrm>
-            <a:off x="1599783" y="173570"/>
+            <a:off x="1599783" y="262239"/>
             <a:ext cx="8989258" cy="4219447"/>
           </a:xfrm>
           <a:prstGeom prst="rect">

</xml_diff>

<commit_message>
slides and presentation calibration
</commit_message>
<xml_diff>
--- a/presentation.pptx
+++ b/presentation.pptx
@@ -4714,8 +4714,8 @@
         </p:nvSpPr>
         <p:spPr>
           <a:xfrm>
-            <a:off x="1552353" y="2007219"/>
-            <a:ext cx="2987749" cy="4414845"/>
+            <a:off x="1552353" y="863601"/>
+            <a:ext cx="2987749" cy="5558464"/>
           </a:xfrm>
         </p:spPr>
         <p:txBody>
@@ -4731,7 +4731,18 @@
                   <a:srgbClr val="FFFFFF"/>
                 </a:solidFill>
               </a:rPr>
-              <a:t>Rigged rock-paper-scissors project on Raspberry Pi 3</a:t>
+              <a:t>Rigged rock-paper-scissors project on a</a:t>
+            </a:r>
+          </a:p>
+          <a:p>
+            <a:pPr algn="r"/>
+            <a:r>
+              <a:rPr lang="en-GB" dirty="0">
+                <a:solidFill>
+                  <a:srgbClr val="FFFFFF"/>
+                </a:solidFill>
+              </a:rPr>
+              <a:t>Raspberry PI 3 </a:t>
             </a:r>
           </a:p>
           <a:p>
@@ -4744,6 +4755,30 @@
           </a:p>
           <a:p>
             <a:pPr algn="r"/>
+            <a:endParaRPr lang="en-GB" dirty="0">
+              <a:solidFill>
+                <a:srgbClr val="FFFFFF"/>
+              </a:solidFill>
+            </a:endParaRPr>
+          </a:p>
+          <a:p>
+            <a:pPr algn="r"/>
+            <a:endParaRPr lang="en-GB" dirty="0">
+              <a:solidFill>
+                <a:srgbClr val="FFFFFF"/>
+              </a:solidFill>
+            </a:endParaRPr>
+          </a:p>
+          <a:p>
+            <a:pPr algn="r"/>
+            <a:endParaRPr lang="en-GB" dirty="0">
+              <a:solidFill>
+                <a:srgbClr val="FFFFFF"/>
+              </a:solidFill>
+            </a:endParaRPr>
+          </a:p>
+          <a:p>
+            <a:pPr algn="r"/>
             <a:r>
               <a:rPr lang="en-GB" dirty="0">
                 <a:solidFill>
@@ -4795,6 +4830,42 @@
           </a:p>
         </p:txBody>
       </p:sp>
+      <p:pic>
+        <p:nvPicPr>
+          <p:cNvPr id="16" name="Picture 15" descr="Raspberry Pi">
+            <a:extLst>
+              <a:ext uri="{FF2B5EF4-FFF2-40B4-BE49-F238E27FC236}">
+                <a16:creationId xmlns:a16="http://schemas.microsoft.com/office/drawing/2014/main" id="{61BDB660-9BE6-862F-BE73-D5DAC4791F26}"/>
+              </a:ext>
+            </a:extLst>
+          </p:cNvPr>
+          <p:cNvPicPr>
+            <a:picLocks noChangeAspect="1"/>
+          </p:cNvPicPr>
+          <p:nvPr/>
+        </p:nvPicPr>
+        <p:blipFill>
+          <a:blip r:embed="rId3">
+            <a:extLst>
+              <a:ext uri="{837473B0-CC2E-450A-ABE3-18F120FF3D39}">
+                <a1611:picAttrSrcUrl xmlns:a1611="http://schemas.microsoft.com/office/drawing/2016/11/main" r:id="rId4"/>
+              </a:ext>
+            </a:extLst>
+          </a:blip>
+          <a:stretch>
+            <a:fillRect/>
+          </a:stretch>
+        </p:blipFill>
+        <p:spPr>
+          <a:xfrm>
+            <a:off x="938551" y="1932305"/>
+            <a:ext cx="1858549" cy="2342074"/>
+          </a:xfrm>
+          <a:prstGeom prst="rect">
+            <a:avLst/>
+          </a:prstGeom>
+        </p:spPr>
+      </p:pic>
     </p:spTree>
   </p:cSld>
   <p:clrMapOvr>
@@ -4846,7 +4917,7 @@
         </p:nvSpPr>
         <p:spPr>
           <a:xfrm>
-            <a:off x="1599783" y="4816249"/>
+            <a:off x="1599783" y="4941671"/>
             <a:ext cx="8989258" cy="1645759"/>
           </a:xfrm>
         </p:spPr>
@@ -4866,10 +4937,10 @@
       </p:sp>
       <p:pic>
         <p:nvPicPr>
-          <p:cNvPr id="5" name="Picture 4" descr="A screenshot of a computer program&#10;&#10;AI-generated content may be incorrect.">
+          <p:cNvPr id="3" name="Picture 2">
             <a:extLst>
               <a:ext uri="{FF2B5EF4-FFF2-40B4-BE49-F238E27FC236}">
-                <a16:creationId xmlns:a16="http://schemas.microsoft.com/office/drawing/2014/main" id="{A7364D52-A79E-55DA-9FB6-BF2ECA8C5008}"/>
+                <a16:creationId xmlns:a16="http://schemas.microsoft.com/office/drawing/2014/main" id="{8C8B21BE-286B-1C51-552B-46C835673903}"/>
               </a:ext>
             </a:extLst>
           </p:cNvPr>
@@ -4886,8 +4957,8 @@
         </p:blipFill>
         <p:spPr>
           <a:xfrm>
-            <a:off x="1599783" y="262239"/>
-            <a:ext cx="8989258" cy="4219447"/>
+            <a:off x="1599783" y="60408"/>
+            <a:ext cx="8989258" cy="4583089"/>
           </a:xfrm>
           <a:prstGeom prst="rect">
             <a:avLst/>
@@ -5171,7 +5242,7 @@
         </p:spPr>
         <p:txBody>
           <a:bodyPr>
-            <a:normAutofit/>
+            <a:normAutofit fontScale="92500" lnSpcReduction="20000"/>
           </a:bodyPr>
           <a:lstStyle/>
           <a:p>
@@ -5186,7 +5257,7 @@
                   <a:schemeClr val="tx1"/>
                 </a:solidFill>
               </a:rPr>
-              <a:t>Goal: ONLY the chosen accessory enables wins; other coloured items must not trigger it</a:t>
+              <a:t>Goal: ONLY the chosen pink accessory enables wins</a:t>
             </a:r>
           </a:p>
           <a:p>
@@ -5201,129 +5272,7 @@
                   <a:schemeClr val="tx1"/>
                 </a:solidFill>
               </a:rPr>
-              <a:t>Approach: HSV mask + per-startup baseline (no second neural network needed)</a:t>
-            </a:r>
-          </a:p>
-          <a:p>
-            <a:pPr lvl="1">
-              <a:lnSpc>
-                <a:spcPct val="90000"/>
-              </a:lnSpc>
-            </a:pPr>
-            <a:r>
-              <a:rPr lang="en-GB" dirty="0">
-                <a:solidFill>
-                  <a:schemeClr val="tx1"/>
-                </a:solidFill>
-              </a:rPr>
-              <a:t>cv::</a:t>
-            </a:r>
-            <a:r>
-              <a:rPr lang="en-GB" dirty="0" err="1">
-                <a:solidFill>
-                  <a:schemeClr val="tx1"/>
-                </a:solidFill>
-              </a:rPr>
-              <a:t>cvtColor</a:t>
-            </a:r>
-            <a:r>
-              <a:rPr lang="en-GB" dirty="0">
-                <a:solidFill>
-                  <a:schemeClr val="tx1"/>
-                </a:solidFill>
-              </a:rPr>
-              <a:t>(RGB-&gt;HSV) -&gt; cv::</a:t>
-            </a:r>
-            <a:r>
-              <a:rPr lang="en-GB" dirty="0" err="1">
-                <a:solidFill>
-                  <a:schemeClr val="tx1"/>
-                </a:solidFill>
-              </a:rPr>
-              <a:t>inRange</a:t>
-            </a:r>
-            <a:r>
-              <a:rPr lang="en-GB" dirty="0">
-                <a:solidFill>
-                  <a:schemeClr val="tx1"/>
-                </a:solidFill>
-              </a:rPr>
-              <a:t>(hue/sat/</a:t>
-            </a:r>
-            <a:r>
-              <a:rPr lang="en-GB" dirty="0" err="1">
-                <a:solidFill>
-                  <a:schemeClr val="tx1"/>
-                </a:solidFill>
-              </a:rPr>
-              <a:t>val</a:t>
-            </a:r>
-            <a:r>
-              <a:rPr lang="en-GB" dirty="0">
-                <a:solidFill>
-                  <a:schemeClr val="tx1"/>
-                </a:solidFill>
-              </a:rPr>
-              <a:t> bounds) -&gt; cv::</a:t>
-            </a:r>
-            <a:r>
-              <a:rPr lang="en-GB" dirty="0" err="1">
-                <a:solidFill>
-                  <a:schemeClr val="tx1"/>
-                </a:solidFill>
-              </a:rPr>
-              <a:t>countNonZero</a:t>
-            </a:r>
-            <a:endParaRPr lang="en-GB" dirty="0">
-              <a:solidFill>
-                <a:schemeClr val="tx1"/>
-              </a:solidFill>
-            </a:endParaRPr>
-          </a:p>
-          <a:p>
-            <a:pPr lvl="1">
-              <a:lnSpc>
-                <a:spcPct val="90000"/>
-              </a:lnSpc>
-            </a:pPr>
-            <a:r>
-              <a:rPr lang="en-GB" dirty="0">
-                <a:solidFill>
-                  <a:schemeClr val="tx1"/>
-                </a:solidFill>
-              </a:rPr>
-              <a:t>Calibrate baseline by averaging 60 empty-scene frames at startup</a:t>
-            </a:r>
-          </a:p>
-          <a:p>
-            <a:pPr lvl="1">
-              <a:lnSpc>
-                <a:spcPct val="90000"/>
-              </a:lnSpc>
-            </a:pPr>
-            <a:r>
-              <a:rPr lang="en-GB" dirty="0">
-                <a:solidFill>
-                  <a:schemeClr val="tx1"/>
-                </a:solidFill>
-              </a:rPr>
-              <a:t>'Present' if live count &gt; baseline * </a:t>
-            </a:r>
-            <a:r>
-              <a:rPr lang="en-GB" dirty="0" err="1">
-                <a:solidFill>
-                  <a:schemeClr val="tx1"/>
-                </a:solidFill>
-              </a:rPr>
-              <a:t>threshold_multiplier</a:t>
-            </a:r>
-            <a:r>
-              <a:rPr lang="en-GB" dirty="0">
-                <a:solidFill>
-                  <a:schemeClr val="tx1"/>
-                </a:solidFill>
-              </a:rPr>
-              <a:t> (default 1.25)</a:t>
+              <a:t>Approach: HSV mask + per-startup baseline + per-round majority vote (no second neural network needed)</a:t>
             </a:r>
           </a:p>
           <a:p>
@@ -5333,12 +5282,20 @@
               </a:lnSpc>
             </a:pPr>
             <a:r>
+              <a:rPr lang="en-GB" dirty="0">
+                <a:solidFill>
+                  <a:schemeClr val="tx1"/>
+                </a:solidFill>
+              </a:rPr>
+              <a:t>Per-frame trigger: 'present' if count &gt; max(baseline * threshold_multiplier, </a:t>
+            </a:r>
+            <a:r>
               <a:rPr lang="en-GB" dirty="0" err="1">
                 <a:solidFill>
                   <a:schemeClr val="tx1"/>
                 </a:solidFill>
               </a:rPr>
-              <a:t>Tunable</a:t>
+              <a:t>min_threshold</a:t>
             </a:r>
             <a:r>
               <a:rPr lang="en-GB" dirty="0">
@@ -5346,38 +5303,45 @@
                   <a:schemeClr val="tx1"/>
                 </a:solidFill>
               </a:rPr>
-              <a:t> without rebuild via </a:t>
-            </a:r>
-            <a:r>
-              <a:rPr lang="en-GB" dirty="0" err="1">
-                <a:solidFill>
-                  <a:schemeClr val="tx1"/>
-                </a:solidFill>
-              </a:rPr>
-              <a:t>accessory.conf</a:t>
-            </a:r>
-            <a:r>
-              <a:rPr lang="en-GB" dirty="0">
-                <a:solidFill>
-                  <a:schemeClr val="tx1"/>
-                </a:solidFill>
-              </a:rPr>
-              <a:t>:</a:t>
-            </a:r>
-          </a:p>
-          <a:p>
-            <a:pPr lvl="1">
+              <a:t>)</a:t>
+            </a:r>
+          </a:p>
+          <a:p>
+            <a:pPr>
               <a:lnSpc>
                 <a:spcPct val="90000"/>
               </a:lnSpc>
             </a:pPr>
             <a:r>
+              <a:rPr lang="en-GB" dirty="0">
+                <a:solidFill>
+                  <a:schemeClr val="tx1"/>
+                </a:solidFill>
+              </a:rPr>
+              <a:t>Per-round smoothing: the gesture window also majority-votes the accessory bool, so one glitched frame cannot flip the rigging</a:t>
+            </a:r>
+          </a:p>
+          <a:p>
+            <a:pPr>
+              <a:lnSpc>
+                <a:spcPct val="90000"/>
+              </a:lnSpc>
+            </a:pPr>
+            <a:r>
+              <a:rPr lang="en-GB" dirty="0">
+                <a:solidFill>
+                  <a:schemeClr val="tx1"/>
+                </a:solidFill>
+              </a:rPr>
+              <a:t>Tunable without rebuild via </a:t>
+            </a:r>
+            <a:r>
               <a:rPr lang="en-GB" dirty="0" err="1">
                 <a:solidFill>
                   <a:schemeClr val="tx1"/>
                 </a:solidFill>
               </a:rPr>
-              <a:t>hue_min</a:t>
+              <a:t>accessory.conf</a:t>
             </a:r>
             <a:r>
               <a:rPr lang="en-GB" dirty="0">
@@ -5385,69 +5349,23 @@
                   <a:schemeClr val="tx1"/>
                 </a:solidFill>
               </a:rPr>
-              <a:t>/max, </a:t>
-            </a:r>
-            <a:r>
-              <a:rPr lang="en-GB" dirty="0" err="1">
+              <a:t>:</a:t>
+            </a:r>
+          </a:p>
+          <a:p>
+            <a:pPr>
+              <a:lnSpc>
+                <a:spcPct val="90000"/>
+              </a:lnSpc>
+            </a:pPr>
+            <a:r>
+              <a:rPr lang="en-GB" dirty="0">
                 <a:solidFill>
                   <a:schemeClr val="tx1"/>
                 </a:solidFill>
               </a:rPr>
-              <a:t>sat_min</a:t>
-            </a:r>
-            <a:r>
-              <a:rPr lang="en-GB" dirty="0">
-                <a:solidFill>
-                  <a:schemeClr val="tx1"/>
-                </a:solidFill>
-              </a:rPr>
-              <a:t>/max, </a:t>
-            </a:r>
-            <a:r>
-              <a:rPr lang="en-GB" dirty="0" err="1">
-                <a:solidFill>
-                  <a:schemeClr val="tx1"/>
-                </a:solidFill>
-              </a:rPr>
-              <a:t>val_min</a:t>
-            </a:r>
-            <a:r>
-              <a:rPr lang="en-GB" dirty="0">
-                <a:solidFill>
-                  <a:schemeClr val="tx1"/>
-                </a:solidFill>
-              </a:rPr>
-              <a:t>/max, </a:t>
-            </a:r>
-            <a:r>
-              <a:rPr lang="en-GB" dirty="0" err="1">
-                <a:solidFill>
-                  <a:schemeClr val="tx1"/>
-                </a:solidFill>
-              </a:rPr>
-              <a:t>calibration_frames</a:t>
-            </a:r>
-            <a:r>
-              <a:rPr lang="en-GB" dirty="0">
-                <a:solidFill>
-                  <a:schemeClr val="tx1"/>
-                </a:solidFill>
-              </a:rPr>
-              <a:t>, </a:t>
-            </a:r>
-            <a:r>
-              <a:rPr lang="en-GB" dirty="0" err="1">
-                <a:solidFill>
-                  <a:schemeClr val="tx1"/>
-                </a:solidFill>
-              </a:rPr>
-              <a:t>threshold_multiplier</a:t>
-            </a:r>
-            <a:endParaRPr lang="en-GB" dirty="0">
-              <a:solidFill>
-                <a:schemeClr val="tx1"/>
-              </a:solidFill>
-            </a:endParaRPr>
+              <a:t>Current values (pink wristband): H 120-175, S 35-255, V 31-183, 60 frames, multiplier 10, floor 500 px</a:t>
+            </a:r>
           </a:p>
           <a:p>
             <a:pPr>
@@ -6260,7 +6178,7 @@
           <a:p>
             <a:r>
               <a:rPr dirty="0"/>
-              <a:t>Live demo</a:t>
+              <a:t>demo</a:t>
             </a:r>
           </a:p>
         </p:txBody>
@@ -9921,7 +9839,7 @@
         </p:spPr>
         <p:txBody>
           <a:bodyPr vert="horz" lIns="91440" tIns="45720" rIns="91440" bIns="45720" rtlCol="0">
-            <a:normAutofit lnSpcReduction="10000"/>
+            <a:normAutofit fontScale="92500" lnSpcReduction="20000"/>
           </a:bodyPr>
           <a:lstStyle/>
           <a:p>
@@ -10052,7 +9970,7 @@
             </a:r>
           </a:p>
           <a:p>
-            <a:pPr indent="-228600" defTabSz="914400">
+            <a:pPr lvl="1" indent="-228600" defTabSz="914400">
               <a:lnSpc>
                 <a:spcPct val="90000"/>
               </a:lnSpc>
@@ -10067,7 +9985,7 @@
             </a:pPr>
             <a:r>
               <a:rPr lang="en-US" sz="1600" dirty="0"/>
-              <a:t>   Cheap cv::</a:t>
+              <a:t>Cheap cv::</a:t>
             </a:r>
             <a:r>
               <a:rPr lang="en-US" sz="1600" dirty="0" err="1"/>
@@ -10083,7 +10001,26 @@
             </a:r>
             <a:r>
               <a:rPr lang="en-US" sz="1600" dirty="0"/>
-              <a:t> -&gt; 'present' if count &gt; baseline * 1.25.</a:t>
+              <a:t> -&gt; 'present' if count &gt; baseline * 10.</a:t>
+            </a:r>
+          </a:p>
+          <a:p>
+            <a:pPr lvl="1" indent="-228600" defTabSz="914400">
+              <a:lnSpc>
+                <a:spcPct val="90000"/>
+              </a:lnSpc>
+              <a:spcBef>
+                <a:spcPts val="1000"/>
+              </a:spcBef>
+              <a:buClr>
+                <a:schemeClr val="accent2"/>
+              </a:buClr>
+              <a:buFont typeface="Arial" panose="020B0604020202020204" pitchFamily="34" charset="0"/>
+              <a:buChar char="•"/>
+            </a:pPr>
+            <a:r>
+              <a:rPr lang="en-US" sz="1600" dirty="0"/>
+              <a:t>as well as a floor of pixels found at 500</a:t>
             </a:r>
           </a:p>
           <a:p>

</xml_diff>